<commit_message>
fix: PPT — retirer admin secret/audit + corriger nombre pharmacies + retirer GitHub
Slide 7 (Sécurité):
- Retrait des cartes 'Admin secret' et 'Tout est tracé'
- Grille passée de 4x2 (8 cartes) à 3x2 (6 cartes)

Slides 2, 6, 8, 9, 10:
- Remplacement de '1348 pharmacies' par 'une centaine de pharmacies'
- Explication: pharmacies qui se répartissent la garde à tour de rôle

Slide 9 + 11:
- Retrait de la mention 'Code source sur GitHub'
</commit_message>
<xml_diff>
--- a/download/MediTike-Presentation.pptx
+++ b/download/MediTike-Presentation.pptx
@@ -791,7 +791,7 @@
               <a:t>- Décrire la situation vécue par les patients sans jargon technique.
 - Insister sur le temps perdu : appeler plusieurs pharmacies, tomber sur le répondeur.
 - Rappeler que la liste officielle existe mais est difficile à trouver.
-- Souligner les 3 chiffres : 1348 pharmacies, 26 semaines, plus de 30 minutes en moyenne.
+- Souligner les 3 chiffres : une centaine de pharmacies, 26 semaines, plus de 30 minutes en moyenne.
 - Préparer la transition vers l'idée MediTike.</a:t>
             </a:r>
             <a:endParaRPr lang="en-US" dirty="0"/>
@@ -1251,7 +1251,6 @@
               <a:t>- Insister sur l'auto-suppression des photos après 72 heures ou 7 jours.
 - Rassurer : même l'équipe MediTike ne peut pas voir les mots de passe.
 - Mentionner que la connexion est chiffrée comme pour les banques.
-- Expliquer que l'accès administrateur est caché et que tout est enregistré.
 - Conclure : confidentialité et sécurité sont au cœur du projet.</a:t>
             </a:r>
             <a:endParaRPr lang="en-US" dirty="0"/>
@@ -1342,7 +1341,7 @@
               <a:rPr lang="en-US" dirty="0"/>
               <a:t>- Mettre en avant l'impact concret pour les gens, pas la technique.
 - Insister sur le passage de 30 minutes à moins de 5 minutes pour trouver une pharmacie.
-- Rappeler que les 1348 pharmacies officielles sont toutes couvertes.
+- Rappeler que les pharmacies officielles sont toutes couvertes.
 - Mentionner les 7 villes desservies et la suppression automatique des photos.
 - Conclure avec la citation : solution simple et accessible, même avec une connexion modeste.</a:t>
             </a:r>
@@ -1433,7 +1432,7 @@
             <a:r>
               <a:rPr lang="en-US" dirty="0"/>
               <a:t>- Insister sur le fait que l'application est déjà en service, pas juste une idée.
-- Énumérer ce qui est fait : en ligne, photos sécurisées, ménage automatique, 1348 pharmacies.
+- Énumérer ce qui est fait : en ligne, photos sécurisées, ménage automatique, pharmacies importées.
 - Présenter la feuille de route en 3 horizons : 3 mois, 6-12 mois, long terme.
 - Mettre en avant WhatsApp, Mobile Money et l'extension à d'autres pays.
 - Conclure : MediTike est concret aujourd'hui, et a une vision pour demain.</a:t>
@@ -3693,7 +3692,7 @@
                 <a:ea typeface="Carlito" pitchFamily="34" charset="-122"/>
                 <a:cs typeface="Carlito" pitchFamily="34" charset="-120"/>
               </a:rPr>
-              <a:t>Ce n'est pas juste une idée sur papier. L'application fonctionne, elle est en ligne, et 1348 pharmacies de garde y sont déjà répertoriées. On peut l'utiliser dès aujourd'hui.</a:t>
+              <a:t>Ce n'est pas juste une idée sur papier. L'application fonctionne, elle est en ligne, et les pharmacies de garde y sont déjà répertoriées. On peut l'utiliser dès aujourd'hui.</a:t>
             </a:r>
             <a:endParaRPr lang="en-US" sz="800" dirty="0"/>
           </a:p>
@@ -4694,7 +4693,7 @@
         </p:blipFill>
         <p:spPr>
           <a:xfrm>
-            <a:off x="4147951" y="1165547"/>
+            <a:off x="4147951" y="1224483"/>
             <a:ext cx="228600" cy="228600"/>
           </a:xfrm>
           <a:prstGeom prst="rect">
@@ -4710,7 +4709,7 @@
         </p:nvSpPr>
         <p:spPr>
           <a:xfrm>
-            <a:off x="4147951" y="1165547"/>
+            <a:off x="4147951" y="1224483"/>
             <a:ext cx="228600" cy="228600"/>
           </a:xfrm>
           <a:prstGeom prst="rect">
@@ -4752,7 +4751,7 @@
         </p:nvSpPr>
         <p:spPr>
           <a:xfrm>
-            <a:off x="4371276" y="1183407"/>
+            <a:off x="4371276" y="1242343"/>
             <a:ext cx="701373" cy="208312"/>
           </a:xfrm>
           <a:prstGeom prst="rect">
@@ -4794,7 +4793,7 @@
         </p:nvSpPr>
         <p:spPr>
           <a:xfrm>
-            <a:off x="274320" y="1594172"/>
+            <a:off x="274320" y="1653108"/>
             <a:ext cx="8595248" cy="388776"/>
           </a:xfrm>
           <a:prstGeom prst="rect">
@@ -4836,7 +4835,7 @@
         </p:nvSpPr>
         <p:spPr>
           <a:xfrm>
-            <a:off x="274320" y="2025588"/>
+            <a:off x="274320" y="2084524"/>
             <a:ext cx="8595248" cy="231458"/>
           </a:xfrm>
           <a:prstGeom prst="rect">
@@ -4880,7 +4879,7 @@
         </p:nvSpPr>
         <p:spPr>
           <a:xfrm>
-            <a:off x="1914525" y="2397063"/>
+            <a:off x="1914525" y="2455999"/>
             <a:ext cx="200025" cy="200025"/>
           </a:xfrm>
           <a:prstGeom prst="rect">
@@ -4919,7 +4918,7 @@
         </p:nvSpPr>
         <p:spPr>
           <a:xfrm>
-            <a:off x="2071688" y="2454213"/>
+            <a:off x="2071688" y="2513149"/>
             <a:ext cx="5000625" cy="430366"/>
           </a:xfrm>
           <a:prstGeom prst="rect">
@@ -4961,7 +4960,7 @@
         </p:nvSpPr>
         <p:spPr>
           <a:xfrm>
-            <a:off x="2899023" y="3092016"/>
+            <a:off x="2899023" y="3150952"/>
             <a:ext cx="128588" cy="128588"/>
           </a:xfrm>
           <a:prstGeom prst="rect">
@@ -5000,7 +4999,7 @@
         </p:nvSpPr>
         <p:spPr>
           <a:xfrm>
-            <a:off x="2986297" y="3081300"/>
+            <a:off x="2986297" y="3140236"/>
             <a:ext cx="978387" cy="164592"/>
           </a:xfrm>
           <a:prstGeom prst="rect">
@@ -5042,7 +5041,7 @@
         </p:nvSpPr>
         <p:spPr>
           <a:xfrm>
-            <a:off x="3956554" y="3081300"/>
+            <a:off x="3956554" y="3140236"/>
             <a:ext cx="91440" cy="164592"/>
           </a:xfrm>
           <a:prstGeom prst="rect">
@@ -5084,7 +5083,7 @@
         </p:nvSpPr>
         <p:spPr>
           <a:xfrm>
-            <a:off x="4099620" y="3092016"/>
+            <a:off x="4099620" y="3150952"/>
             <a:ext cx="128588" cy="128588"/>
           </a:xfrm>
           <a:prstGeom prst="rect">
@@ -5123,7 +5122,7 @@
         </p:nvSpPr>
         <p:spPr>
           <a:xfrm>
-            <a:off x="4200978" y="3081300"/>
+            <a:off x="4200978" y="3140236"/>
             <a:ext cx="1149907" cy="164592"/>
           </a:xfrm>
           <a:prstGeom prst="rect">
@@ -5165,7 +5164,7 @@
         </p:nvSpPr>
         <p:spPr>
           <a:xfrm>
-            <a:off x="5356840" y="3081300"/>
+            <a:off x="5356840" y="3140236"/>
             <a:ext cx="91440" cy="164592"/>
           </a:xfrm>
           <a:prstGeom prst="rect">
@@ -5207,7 +5206,7 @@
         </p:nvSpPr>
         <p:spPr>
           <a:xfrm>
-            <a:off x="5499906" y="3092016"/>
+            <a:off x="5499906" y="3150952"/>
             <a:ext cx="128588" cy="128588"/>
           </a:xfrm>
           <a:prstGeom prst="rect">
@@ -5246,7 +5245,7 @@
         </p:nvSpPr>
         <p:spPr>
           <a:xfrm>
-            <a:off x="5637541" y="3081300"/>
+            <a:off x="5637541" y="3140236"/>
             <a:ext cx="655539" cy="164592"/>
           </a:xfrm>
           <a:prstGeom prst="rect">
@@ -5288,7 +5287,7 @@
         </p:nvSpPr>
         <p:spPr>
           <a:xfrm>
-            <a:off x="2867791" y="3432830"/>
+            <a:off x="2867791" y="3491766"/>
             <a:ext cx="1174433" cy="268491"/>
           </a:xfrm>
           <a:prstGeom prst="roundRect">
@@ -5327,7 +5326,7 @@
         </p:nvSpPr>
         <p:spPr>
           <a:xfrm>
-            <a:off x="3154970" y="3517069"/>
+            <a:off x="3154970" y="3576005"/>
             <a:ext cx="742950" cy="100013"/>
           </a:xfrm>
           <a:prstGeom prst="rect">
@@ -5369,7 +5368,7 @@
         </p:nvSpPr>
         <p:spPr>
           <a:xfrm>
-            <a:off x="3012095" y="3517069"/>
+            <a:off x="3012095" y="3576005"/>
             <a:ext cx="100013" cy="100013"/>
           </a:xfrm>
           <a:prstGeom prst="rect">
@@ -5408,7 +5407,7 @@
         </p:nvSpPr>
         <p:spPr>
           <a:xfrm>
-            <a:off x="4067941" y="3432830"/>
+            <a:off x="4067941" y="3491766"/>
             <a:ext cx="1098419" cy="268491"/>
           </a:xfrm>
           <a:prstGeom prst="roundRect">
@@ -5447,7 +5446,7 @@
         </p:nvSpPr>
         <p:spPr>
           <a:xfrm>
-            <a:off x="4355120" y="3517069"/>
+            <a:off x="4355120" y="3576005"/>
             <a:ext cx="666936" cy="100013"/>
           </a:xfrm>
           <a:prstGeom prst="rect">
@@ -5489,7 +5488,7 @@
         </p:nvSpPr>
         <p:spPr>
           <a:xfrm>
-            <a:off x="4212245" y="3517069"/>
+            <a:off x="4212245" y="3576005"/>
             <a:ext cx="100013" cy="100013"/>
           </a:xfrm>
           <a:prstGeom prst="rect">
@@ -5528,7 +5527,7 @@
         </p:nvSpPr>
         <p:spPr>
           <a:xfrm>
-            <a:off x="5192078" y="3432830"/>
+            <a:off x="5192078" y="3491766"/>
             <a:ext cx="1084019" cy="268491"/>
           </a:xfrm>
           <a:prstGeom prst="roundRect">
@@ -5567,7 +5566,7 @@
         </p:nvSpPr>
         <p:spPr>
           <a:xfrm>
-            <a:off x="5479256" y="3517069"/>
+            <a:off x="5479256" y="3576005"/>
             <a:ext cx="652537" cy="100013"/>
           </a:xfrm>
           <a:prstGeom prst="rect">
@@ -5609,7 +5608,7 @@
         </p:nvSpPr>
         <p:spPr>
           <a:xfrm>
-            <a:off x="5336381" y="3517069"/>
+            <a:off x="5336381" y="3576005"/>
             <a:ext cx="100013" cy="100013"/>
           </a:xfrm>
           <a:prstGeom prst="rect">
@@ -5637,89 +5636,6 @@
               <a:t>♥</a:t>
             </a:r>
             <a:endParaRPr lang="en-US" sz="984" dirty="0"/>
-          </a:p>
-        </p:txBody>
-      </p:sp>
-      <p:sp>
-        <p:nvSpPr>
-          <p:cNvPr id="30" name="Text 25"/>
-          <p:cNvSpPr/>
-          <p:nvPr/>
-        </p:nvSpPr>
-        <p:spPr>
-          <a:xfrm>
-            <a:off x="3482690" y="3876042"/>
-            <a:ext cx="91440" cy="91440"/>
-          </a:xfrm>
-          <a:prstGeom prst="rect">
-            <a:avLst/>
-          </a:prstGeom>
-          <a:noFill/>
-          <a:ln/>
-        </p:spPr>
-        <p:txBody>
-          <a:bodyPr wrap="none" lIns="0" tIns="0" rIns="0" bIns="0" rtlCol="0" anchor="ctr"/>
-          <a:lstStyle/>
-          <a:p>
-            <a:pPr algn="ctr" indent="0" marL="0">
-              <a:buNone/>
-            </a:pPr>
-            <a:r>
-              <a:rPr lang="en-US" sz="844" dirty="0">
-                <a:solidFill>
-                  <a:srgbClr val="F5F3EF"/>
-                </a:solidFill>
-                <a:latin typeface="Segoe UI Symbol" pitchFamily="34" charset="0"/>
-                <a:ea typeface="Segoe UI Symbol" pitchFamily="34" charset="-122"/>
-                <a:cs typeface="Segoe UI Symbol" pitchFamily="34" charset="-120"/>
-              </a:rPr>
-              <a:t>✦</a:t>
-            </a:r>
-            <a:endParaRPr lang="en-US" sz="844" dirty="0"/>
-          </a:p>
-        </p:txBody>
-      </p:sp>
-      <p:sp>
-        <p:nvSpPr>
-          <p:cNvPr id="31" name="Text 26"/>
-          <p:cNvSpPr/>
-          <p:nvPr/>
-        </p:nvSpPr>
-        <p:spPr>
-          <a:xfrm>
-            <a:off x="3611277" y="3859969"/>
-            <a:ext cx="2050033" cy="164592"/>
-          </a:xfrm>
-          <a:prstGeom prst="rect">
-            <a:avLst/>
-          </a:prstGeom>
-          <a:noFill/>
-          <a:ln/>
-        </p:spPr>
-        <p:txBody>
-          <a:bodyPr wrap="square" lIns="0" tIns="0" rIns="0" bIns="0" rtlCol="0" anchor="t"/>
-          <a:lstStyle/>
-          <a:p>
-            <a:pPr algn="ctr" indent="0" marL="0">
-              <a:lnSpc>
-                <a:spcPts val="928"/>
-              </a:lnSpc>
-              <a:buNone/>
-            </a:pPr>
-            <a:r>
-              <a:rPr lang="en-US" sz="800" spc="25" kern="0" dirty="0">
-                <a:solidFill>
-                  <a:srgbClr val="F5F3EF">
-                    <a:alpha val="70000"/>
-                  </a:srgbClr>
-                </a:solidFill>
-                <a:latin typeface="Carlito" pitchFamily="34" charset="0"/>
-                <a:ea typeface="Carlito" pitchFamily="34" charset="-122"/>
-                <a:cs typeface="Carlito" pitchFamily="34" charset="-120"/>
-              </a:rPr>
-              <a:t>Code source : github.com/kennethafantsawo/MediTike</a:t>
-            </a:r>
-            <a:endParaRPr lang="en-US" sz="800" dirty="0"/>
           </a:p>
         </p:txBody>
       </p:sp>
@@ -6276,7 +6192,7 @@
                 <a:ea typeface="Liberation Sans Narrow" pitchFamily="34" charset="-122"/>
                 <a:cs typeface="Liberation Sans Narrow" pitchFamily="34" charset="-120"/>
               </a:rPr>
-              <a:t>1348</a:t>
+              <a:t>~100</a:t>
             </a:r>
             <a:endParaRPr lang="en-US" sz="3150" dirty="0"/>
           </a:p>
@@ -6330,7 +6246,7 @@
         <p:spPr>
           <a:xfrm>
             <a:off x="692944" y="4309914"/>
-            <a:ext cx="2252625" cy="269230"/>
+            <a:ext cx="2252625" cy="159053"/>
           </a:xfrm>
           <a:prstGeom prst="rect">
             <a:avLst/>
@@ -6357,7 +6273,7 @@
                 <a:ea typeface="Carlito" pitchFamily="34" charset="-122"/>
                 <a:cs typeface="Carlito" pitchFamily="34" charset="-120"/>
               </a:rPr>
-              <a:t>pharmacies de garde répertoriées dans le fichier officiel 2026-2027</a:t>
+              <a:t>pharmacies qui se répartissent la garde à tour de rôle</a:t>
             </a:r>
             <a:endParaRPr lang="en-US" sz="800" dirty="0"/>
           </a:p>
@@ -12562,7 +12478,7 @@
         <p:spPr>
           <a:xfrm>
             <a:off x="5587082" y="1705124"/>
-            <a:ext cx="1473064" cy="1556445"/>
+            <a:ext cx="1473064" cy="1616385"/>
           </a:xfrm>
           <a:prstGeom prst="roundRect">
             <a:avLst>
@@ -12640,7 +12556,7 @@
         </p:nvSpPr>
         <p:spPr>
           <a:xfrm>
-            <a:off x="5704954" y="3009416"/>
+            <a:off x="5704954" y="3069357"/>
             <a:ext cx="1311559" cy="119993"/>
           </a:xfrm>
           <a:prstGeom prst="rect">
@@ -12683,7 +12599,7 @@
         <p:spPr>
           <a:xfrm>
             <a:off x="7153015" y="1705124"/>
-            <a:ext cx="1473064" cy="1556445"/>
+            <a:ext cx="1473064" cy="1616385"/>
           </a:xfrm>
           <a:prstGeom prst="roundRect">
             <a:avLst>
@@ -12747,7 +12663,7 @@
                 <a:ea typeface="Liberation Sans Narrow" pitchFamily="34" charset="-122"/>
                 <a:cs typeface="Liberation Sans Narrow" pitchFamily="34" charset="-120"/>
               </a:rPr>
-              <a:t>1348</a:t>
+              <a:t>~100</a:t>
             </a:r>
             <a:endParaRPr lang="en-US" sz="2025" dirty="0"/>
           </a:p>
@@ -12761,8 +12677,8 @@
         </p:nvSpPr>
         <p:spPr>
           <a:xfrm>
-            <a:off x="7270886" y="3009416"/>
-            <a:ext cx="1311559" cy="119993"/>
+            <a:off x="7270886" y="2949364"/>
+            <a:ext cx="1237320" cy="239985"/>
           </a:xfrm>
           <a:prstGeom prst="rect">
             <a:avLst/>
@@ -12789,7 +12705,7 @@
                 <a:ea typeface="Carlito" pitchFamily="34" charset="-122"/>
                 <a:cs typeface="Carlito" pitchFamily="34" charset="-120"/>
               </a:rPr>
-              <a:t>pharmacies de garde importées</a:t>
+              <a:t>pharmacies de garde participantes</a:t>
             </a:r>
             <a:endParaRPr lang="en-US" sz="800" dirty="0"/>
           </a:p>
@@ -12803,8 +12719,8 @@
         </p:nvSpPr>
         <p:spPr>
           <a:xfrm>
-            <a:off x="5587082" y="3354437"/>
-            <a:ext cx="1473064" cy="1556445"/>
+            <a:off x="5587082" y="3414378"/>
+            <a:ext cx="1473064" cy="1496504"/>
           </a:xfrm>
           <a:prstGeom prst="roundRect">
             <a:avLst>
@@ -12840,7 +12756,7 @@
         </p:nvSpPr>
         <p:spPr>
           <a:xfrm>
-            <a:off x="5704954" y="3486596"/>
+            <a:off x="5704954" y="3546537"/>
             <a:ext cx="1237320" cy="277749"/>
           </a:xfrm>
           <a:prstGeom prst="rect">
@@ -12924,8 +12840,8 @@
         </p:nvSpPr>
         <p:spPr>
           <a:xfrm>
-            <a:off x="7153015" y="3354437"/>
-            <a:ext cx="1473064" cy="1556445"/>
+            <a:off x="7153015" y="3414378"/>
+            <a:ext cx="1473064" cy="1496504"/>
           </a:xfrm>
           <a:prstGeom prst="roundRect">
             <a:avLst>
@@ -12961,7 +12877,7 @@
         </p:nvSpPr>
         <p:spPr>
           <a:xfrm>
-            <a:off x="7270886" y="3486596"/>
+            <a:off x="7270886" y="3546537"/>
             <a:ext cx="1237320" cy="277749"/>
           </a:xfrm>
           <a:prstGeom prst="rect">
@@ -13344,11 +13260,11 @@
         <p:spPr>
           <a:xfrm>
             <a:off x="517922" y="1742294"/>
-            <a:ext cx="1946672" cy="1445158"/>
+            <a:ext cx="2621756" cy="1438015"/>
           </a:xfrm>
           <a:prstGeom prst="roundRect">
             <a:avLst>
-              <a:gd name="adj" fmla="val 10546"/>
+              <a:gd name="adj" fmla="val 10598"/>
             </a:avLst>
           </a:prstGeom>
           <a:solidFill>
@@ -13454,7 +13370,7 @@
         <p:spPr>
           <a:xfrm>
             <a:off x="635794" y="2245928"/>
-            <a:ext cx="1710928" cy="154305"/>
+            <a:ext cx="2386013" cy="154305"/>
           </a:xfrm>
           <a:prstGeom prst="rect">
             <a:avLst/>
@@ -13496,7 +13412,7 @@
         <p:spPr>
           <a:xfrm>
             <a:off x="635794" y="2431666"/>
-            <a:ext cx="1710928" cy="340157"/>
+            <a:ext cx="2386013" cy="340157"/>
           </a:xfrm>
           <a:prstGeom prst="rect">
             <a:avLst/>
@@ -13537,12 +13453,12 @@
         </p:nvSpPr>
         <p:spPr>
           <a:xfrm>
-            <a:off x="2571750" y="1742294"/>
-            <a:ext cx="1946672" cy="1445158"/>
+            <a:off x="3261122" y="1742294"/>
+            <a:ext cx="2621756" cy="1438015"/>
           </a:xfrm>
           <a:prstGeom prst="roundRect">
             <a:avLst>
-              <a:gd name="adj" fmla="val 10546"/>
+              <a:gd name="adj" fmla="val 10598"/>
             </a:avLst>
           </a:prstGeom>
           <a:solidFill>
@@ -13574,7 +13490,7 @@
         </p:nvSpPr>
         <p:spPr>
           <a:xfrm>
-            <a:off x="2689622" y="1860166"/>
+            <a:off x="3378994" y="1860166"/>
             <a:ext cx="300038" cy="300038"/>
           </a:xfrm>
           <a:prstGeom prst="roundRect">
@@ -13608,7 +13524,7 @@
         </p:nvSpPr>
         <p:spPr>
           <a:xfrm>
-            <a:off x="2725698" y="1896241"/>
+            <a:off x="3415070" y="1896241"/>
             <a:ext cx="227886" cy="227886"/>
           </a:xfrm>
           <a:prstGeom prst="rect">
@@ -13647,8 +13563,8 @@
         </p:nvSpPr>
         <p:spPr>
           <a:xfrm>
-            <a:off x="2689622" y="2245928"/>
-            <a:ext cx="1710928" cy="154305"/>
+            <a:off x="3378994" y="2245928"/>
+            <a:ext cx="2386012" cy="154305"/>
           </a:xfrm>
           <a:prstGeom prst="rect">
             <a:avLst/>
@@ -13689,8 +13605,8 @@
         </p:nvSpPr>
         <p:spPr>
           <a:xfrm>
-            <a:off x="2689622" y="2431666"/>
-            <a:ext cx="1710928" cy="510235"/>
+            <a:off x="3378994" y="2431666"/>
+            <a:ext cx="2386013" cy="340157"/>
           </a:xfrm>
           <a:prstGeom prst="rect">
             <a:avLst/>
@@ -13731,12 +13647,12 @@
         </p:nvSpPr>
         <p:spPr>
           <a:xfrm>
-            <a:off x="4622006" y="1738722"/>
-            <a:ext cx="1953816" cy="1452302"/>
+            <a:off x="6000750" y="1738722"/>
+            <a:ext cx="2628900" cy="1445158"/>
           </a:xfrm>
           <a:prstGeom prst="roundRect">
             <a:avLst>
-              <a:gd name="adj" fmla="val 10494"/>
+              <a:gd name="adj" fmla="val 10546"/>
             </a:avLst>
           </a:prstGeom>
           <a:solidFill>
@@ -13763,8 +13679,8 @@
         </p:nvSpPr>
         <p:spPr>
           <a:xfrm>
-            <a:off x="4622006" y="1742294"/>
-            <a:ext cx="1953816" cy="0"/>
+            <a:off x="6000750" y="1742294"/>
+            <a:ext cx="2628900" cy="0"/>
           </a:xfrm>
           <a:prstGeom prst="line">
             <a:avLst/>
@@ -13786,8 +13702,8 @@
         </p:nvSpPr>
         <p:spPr>
           <a:xfrm>
-            <a:off x="6572250" y="1738722"/>
-            <a:ext cx="0" cy="1452302"/>
+            <a:off x="8626078" y="1738722"/>
+            <a:ext cx="0" cy="1445158"/>
           </a:xfrm>
           <a:prstGeom prst="line">
             <a:avLst/>
@@ -13809,8 +13725,8 @@
         </p:nvSpPr>
         <p:spPr>
           <a:xfrm>
-            <a:off x="4622006" y="3187452"/>
-            <a:ext cx="1953816" cy="0"/>
+            <a:off x="6000750" y="3180308"/>
+            <a:ext cx="2628900" cy="0"/>
           </a:xfrm>
           <a:prstGeom prst="line">
             <a:avLst/>
@@ -13832,8 +13748,8 @@
         </p:nvSpPr>
         <p:spPr>
           <a:xfrm>
-            <a:off x="4632722" y="1738722"/>
-            <a:ext cx="0" cy="1452302"/>
+            <a:off x="6011466" y="1738722"/>
+            <a:ext cx="0" cy="1445158"/>
           </a:xfrm>
           <a:prstGeom prst="line">
             <a:avLst/>
@@ -13855,7 +13771,7 @@
         </p:nvSpPr>
         <p:spPr>
           <a:xfrm>
-            <a:off x="4757738" y="1860166"/>
+            <a:off x="6136481" y="1860166"/>
             <a:ext cx="300038" cy="300038"/>
           </a:xfrm>
           <a:prstGeom prst="roundRect">
@@ -13889,7 +13805,7 @@
         </p:nvSpPr>
         <p:spPr>
           <a:xfrm>
-            <a:off x="4793813" y="1896241"/>
+            <a:off x="6172557" y="1896241"/>
             <a:ext cx="227886" cy="227886"/>
           </a:xfrm>
           <a:prstGeom prst="rect">
@@ -13928,8 +13844,8 @@
         </p:nvSpPr>
         <p:spPr>
           <a:xfrm>
-            <a:off x="4757738" y="2245928"/>
-            <a:ext cx="1696641" cy="154305"/>
+            <a:off x="6136481" y="2245928"/>
+            <a:ext cx="2371725" cy="154305"/>
           </a:xfrm>
           <a:prstGeom prst="rect">
             <a:avLst/>
@@ -13970,8 +13886,8 @@
         </p:nvSpPr>
         <p:spPr>
           <a:xfrm>
-            <a:off x="4757738" y="2431666"/>
-            <a:ext cx="1696641" cy="510235"/>
+            <a:off x="6136481" y="2431666"/>
+            <a:ext cx="2371725" cy="340157"/>
           </a:xfrm>
           <a:prstGeom prst="rect">
             <a:avLst/>
@@ -14012,12 +13928,12 @@
         </p:nvSpPr>
         <p:spPr>
           <a:xfrm>
-            <a:off x="6675834" y="1738722"/>
-            <a:ext cx="1953816" cy="1452302"/>
+            <a:off x="514350" y="3298180"/>
+            <a:ext cx="2628900" cy="1445270"/>
           </a:xfrm>
           <a:prstGeom prst="roundRect">
             <a:avLst>
-              <a:gd name="adj" fmla="val 10494"/>
+              <a:gd name="adj" fmla="val 10545"/>
             </a:avLst>
           </a:prstGeom>
           <a:solidFill>
@@ -14044,8 +13960,8 @@
         </p:nvSpPr>
         <p:spPr>
           <a:xfrm>
-            <a:off x="6675834" y="1742294"/>
-            <a:ext cx="1953816" cy="0"/>
+            <a:off x="514350" y="3301752"/>
+            <a:ext cx="2628900" cy="0"/>
           </a:xfrm>
           <a:prstGeom prst="line">
             <a:avLst/>
@@ -14067,8 +13983,8 @@
         </p:nvSpPr>
         <p:spPr>
           <a:xfrm>
-            <a:off x="8626078" y="1738722"/>
-            <a:ext cx="0" cy="1452302"/>
+            <a:off x="3139678" y="3298180"/>
+            <a:ext cx="0" cy="1445270"/>
           </a:xfrm>
           <a:prstGeom prst="line">
             <a:avLst/>
@@ -14090,8 +14006,8 @@
         </p:nvSpPr>
         <p:spPr>
           <a:xfrm>
-            <a:off x="6675834" y="3187452"/>
-            <a:ext cx="1953816" cy="0"/>
+            <a:off x="514350" y="4739878"/>
+            <a:ext cx="2628900" cy="0"/>
           </a:xfrm>
           <a:prstGeom prst="line">
             <a:avLst/>
@@ -14113,8 +14029,8 @@
         </p:nvSpPr>
         <p:spPr>
           <a:xfrm>
-            <a:off x="6686550" y="1738722"/>
-            <a:ext cx="0" cy="1452302"/>
+            <a:off x="525066" y="3298180"/>
+            <a:ext cx="0" cy="1445270"/>
           </a:xfrm>
           <a:prstGeom prst="line">
             <a:avLst/>
@@ -14136,7 +14052,7 @@
         </p:nvSpPr>
         <p:spPr>
           <a:xfrm>
-            <a:off x="6811566" y="1860166"/>
+            <a:off x="650081" y="3419624"/>
             <a:ext cx="300038" cy="300038"/>
           </a:xfrm>
           <a:prstGeom prst="roundRect">
@@ -14170,7 +14086,7 @@
         </p:nvSpPr>
         <p:spPr>
           <a:xfrm>
-            <a:off x="6847642" y="1896241"/>
+            <a:off x="686157" y="3455700"/>
             <a:ext cx="227886" cy="227886"/>
           </a:xfrm>
           <a:prstGeom prst="rect">
@@ -14209,8 +14125,8 @@
         </p:nvSpPr>
         <p:spPr>
           <a:xfrm>
-            <a:off x="6811566" y="2245928"/>
-            <a:ext cx="1696641" cy="154305"/>
+            <a:off x="650081" y="3805386"/>
+            <a:ext cx="2371725" cy="154305"/>
           </a:xfrm>
           <a:prstGeom prst="rect">
             <a:avLst/>
@@ -14251,8 +14167,8 @@
         </p:nvSpPr>
         <p:spPr>
           <a:xfrm>
-            <a:off x="6811566" y="2431666"/>
-            <a:ext cx="1696641" cy="510235"/>
+            <a:off x="650081" y="3991124"/>
+            <a:ext cx="2371725" cy="340157"/>
           </a:xfrm>
           <a:prstGeom prst="rect">
             <a:avLst/>
@@ -14293,8 +14209,8 @@
         </p:nvSpPr>
         <p:spPr>
           <a:xfrm>
-            <a:off x="517922" y="3294608"/>
-            <a:ext cx="1946672" cy="1445270"/>
+            <a:off x="3257550" y="3298180"/>
+            <a:ext cx="2628900" cy="1445270"/>
           </a:xfrm>
           <a:prstGeom prst="roundRect">
             <a:avLst>
@@ -14304,6 +14220,34 @@
           <a:solidFill>
             <a:srgbClr val="FFFFFF"/>
           </a:solidFill>
+          <a:ln/>
+        </p:spPr>
+        <p:txBody>
+          <a:bodyPr wrap="square" rtlCol="0" anchor="ctr"/>
+          <a:lstStyle/>
+          <a:p>
+            <a:pPr indent="0" marL="0">
+              <a:buNone/>
+            </a:pPr>
+            <a:endParaRPr lang="en-US" dirty="0"/>
+          </a:p>
+        </p:txBody>
+      </p:sp>
+      <p:sp>
+        <p:nvSpPr>
+          <p:cNvPr id="38" name="Shape 35"/>
+          <p:cNvSpPr/>
+          <p:nvPr/>
+        </p:nvSpPr>
+        <p:spPr>
+          <a:xfrm>
+            <a:off x="3257550" y="3301752"/>
+            <a:ext cx="2628900" cy="0"/>
+          </a:xfrm>
+          <a:prstGeom prst="line">
+            <a:avLst/>
+          </a:prstGeom>
+          <a:noFill/>
           <a:ln w="7144">
             <a:solidFill>
               <a:srgbClr val="E5E0D5"/>
@@ -14311,193 +14255,22 @@
             <a:prstDash val="solid"/>
           </a:ln>
         </p:spPr>
-        <p:txBody>
-          <a:bodyPr wrap="square" rtlCol="0" anchor="ctr"/>
-          <a:lstStyle/>
-          <a:p>
-            <a:pPr indent="0" marL="0">
-              <a:buNone/>
-            </a:pPr>
-            <a:endParaRPr lang="en-US" dirty="0"/>
-          </a:p>
-        </p:txBody>
-      </p:sp>
-      <p:sp>
-        <p:nvSpPr>
-          <p:cNvPr id="38" name="Text 35"/>
-          <p:cNvSpPr/>
-          <p:nvPr/>
-        </p:nvSpPr>
-        <p:spPr>
-          <a:xfrm>
-            <a:off x="635794" y="3412480"/>
-            <a:ext cx="300038" cy="300038"/>
-          </a:xfrm>
-          <a:prstGeom prst="roundRect">
-            <a:avLst>
-              <a:gd name="adj" fmla="val 31746"/>
-            </a:avLst>
-          </a:prstGeom>
-          <a:solidFill>
-            <a:srgbClr val="0F5132">
-              <a:alpha val="8000"/>
-            </a:srgbClr>
-          </a:solidFill>
-          <a:ln/>
-        </p:spPr>
-        <p:txBody>
-          <a:bodyPr wrap="square" rtlCol="0" anchor="ctr"/>
-          <a:lstStyle/>
-          <a:p>
-            <a:pPr indent="0" marL="0">
-              <a:buNone/>
-            </a:pPr>
-            <a:endParaRPr lang="en-US" dirty="0"/>
-          </a:p>
-        </p:txBody>
-      </p:sp>
-      <p:sp>
-        <p:nvSpPr>
-          <p:cNvPr id="39" name="Text 36"/>
-          <p:cNvSpPr/>
-          <p:nvPr/>
-        </p:nvSpPr>
-        <p:spPr>
-          <a:xfrm>
-            <a:off x="671870" y="3448556"/>
-            <a:ext cx="227886" cy="227886"/>
-          </a:xfrm>
-          <a:prstGeom prst="rect">
-            <a:avLst/>
-          </a:prstGeom>
-          <a:noFill/>
-          <a:ln/>
-        </p:spPr>
-        <p:txBody>
-          <a:bodyPr wrap="none" lIns="0" tIns="0" rIns="0" bIns="0" rtlCol="0" anchor="ctr"/>
-          <a:lstStyle/>
-          <a:p>
-            <a:pPr algn="ctr" indent="0" marL="0">
-              <a:buNone/>
-            </a:pPr>
-            <a:r>
-              <a:rPr lang="en-US" sz="1547" dirty="0">
-                <a:solidFill>
-                  <a:srgbClr val="0F5132"/>
-                </a:solidFill>
-                <a:latin typeface="Segoe UI Symbol" pitchFamily="34" charset="0"/>
-                <a:ea typeface="Segoe UI Symbol" pitchFamily="34" charset="-122"/>
-                <a:cs typeface="Segoe UI Symbol" pitchFamily="34" charset="-120"/>
-              </a:rPr>
-              <a:t>⛨</a:t>
-            </a:r>
-            <a:endParaRPr lang="en-US" sz="1547" dirty="0"/>
-          </a:p>
-        </p:txBody>
-      </p:sp>
-      <p:sp>
-        <p:nvSpPr>
-          <p:cNvPr id="40" name="Text 37"/>
-          <p:cNvSpPr/>
-          <p:nvPr/>
-        </p:nvSpPr>
-        <p:spPr>
-          <a:xfrm>
-            <a:off x="635794" y="3798243"/>
-            <a:ext cx="1710928" cy="154305"/>
-          </a:xfrm>
-          <a:prstGeom prst="rect">
-            <a:avLst/>
-          </a:prstGeom>
-          <a:noFill/>
-          <a:ln/>
-        </p:spPr>
-        <p:txBody>
-          <a:bodyPr wrap="none" lIns="0" tIns="0" rIns="0" bIns="0" rtlCol="0" anchor="t"/>
-          <a:lstStyle/>
-          <a:p>
-            <a:pPr algn="l" indent="0" marL="0">
-              <a:lnSpc>
-                <a:spcPts val="1125"/>
-              </a:lnSpc>
-              <a:buNone/>
-            </a:pPr>
-            <a:r>
-              <a:rPr lang="en-US" sz="900" b="1" spc="-18" kern="0" dirty="0">
-                <a:solidFill>
-                  <a:srgbClr val="1A2B22"/>
-                </a:solidFill>
-                <a:latin typeface="Carlito" pitchFamily="34" charset="0"/>
-                <a:ea typeface="Carlito" pitchFamily="34" charset="-122"/>
-                <a:cs typeface="Carlito" pitchFamily="34" charset="-120"/>
-              </a:rPr>
-              <a:t>Admin secret</a:t>
-            </a:r>
-            <a:endParaRPr lang="en-US" sz="900" dirty="0"/>
-          </a:p>
-        </p:txBody>
-      </p:sp>
-      <p:sp>
-        <p:nvSpPr>
-          <p:cNvPr id="41" name="Text 38"/>
-          <p:cNvSpPr/>
-          <p:nvPr/>
-        </p:nvSpPr>
-        <p:spPr>
-          <a:xfrm>
-            <a:off x="635794" y="3983980"/>
-            <a:ext cx="1710928" cy="510235"/>
-          </a:xfrm>
-          <a:prstGeom prst="rect">
-            <a:avLst/>
-          </a:prstGeom>
-          <a:noFill/>
-          <a:ln/>
-        </p:spPr>
-        <p:txBody>
-          <a:bodyPr wrap="square" lIns="0" tIns="0" rIns="0" bIns="0" rtlCol="0" anchor="t"/>
-          <a:lstStyle/>
-          <a:p>
-            <a:pPr algn="l" indent="0" marL="0">
-              <a:lnSpc>
-                <a:spcPts val="1090"/>
-              </a:lnSpc>
-              <a:buNone/>
-            </a:pPr>
-            <a:r>
-              <a:rPr lang="en-US" sz="800" dirty="0">
-                <a:solidFill>
-                  <a:srgbClr val="6B7C72"/>
-                </a:solidFill>
-                <a:latin typeface="Carlito" pitchFamily="34" charset="0"/>
-                <a:ea typeface="Carlito" pitchFamily="34" charset="-122"/>
-                <a:cs typeface="Carlito" pitchFamily="34" charset="-120"/>
-              </a:rPr>
-              <a:t>L'accès administrateur est caché derrière une adresse secrète que personne ne peut deviner.</a:t>
-            </a:r>
-            <a:endParaRPr lang="en-US" sz="800" dirty="0"/>
-          </a:p>
-        </p:txBody>
-      </p:sp>
-      <p:sp>
-        <p:nvSpPr>
-          <p:cNvPr id="42" name="Text 39"/>
-          <p:cNvSpPr/>
-          <p:nvPr/>
-        </p:nvSpPr>
-        <p:spPr>
-          <a:xfrm>
-            <a:off x="2571750" y="3294608"/>
-            <a:ext cx="1946672" cy="1445270"/>
-          </a:xfrm>
-          <a:prstGeom prst="roundRect">
-            <a:avLst>
-              <a:gd name="adj" fmla="val 10545"/>
-            </a:avLst>
-          </a:prstGeom>
-          <a:solidFill>
-            <a:srgbClr val="FFFFFF"/>
-          </a:solidFill>
+      </p:sp>
+      <p:sp>
+        <p:nvSpPr>
+          <p:cNvPr id="39" name="Shape 36"/>
+          <p:cNvSpPr/>
+          <p:nvPr/>
+        </p:nvSpPr>
+        <p:spPr>
+          <a:xfrm>
+            <a:off x="5882878" y="3298180"/>
+            <a:ext cx="0" cy="1445270"/>
+          </a:xfrm>
+          <a:prstGeom prst="line">
+            <a:avLst/>
+          </a:prstGeom>
+          <a:noFill/>
           <a:ln w="7144">
             <a:solidFill>
               <a:srgbClr val="E5E0D5"/>
@@ -14505,216 +14278,17 @@
             <a:prstDash val="solid"/>
           </a:ln>
         </p:spPr>
-        <p:txBody>
-          <a:bodyPr wrap="square" rtlCol="0" anchor="ctr"/>
-          <a:lstStyle/>
-          <a:p>
-            <a:pPr indent="0" marL="0">
-              <a:buNone/>
-            </a:pPr>
-            <a:endParaRPr lang="en-US" dirty="0"/>
-          </a:p>
-        </p:txBody>
-      </p:sp>
-      <p:sp>
-        <p:nvSpPr>
-          <p:cNvPr id="43" name="Text 40"/>
-          <p:cNvSpPr/>
-          <p:nvPr/>
-        </p:nvSpPr>
-        <p:spPr>
-          <a:xfrm>
-            <a:off x="2689622" y="3412480"/>
-            <a:ext cx="300038" cy="300038"/>
-          </a:xfrm>
-          <a:prstGeom prst="roundRect">
-            <a:avLst>
-              <a:gd name="adj" fmla="val 31746"/>
-            </a:avLst>
-          </a:prstGeom>
-          <a:solidFill>
-            <a:srgbClr val="0F5132">
-              <a:alpha val="8000"/>
-            </a:srgbClr>
-          </a:solidFill>
-          <a:ln/>
-        </p:spPr>
-        <p:txBody>
-          <a:bodyPr wrap="square" rtlCol="0" anchor="ctr"/>
-          <a:lstStyle/>
-          <a:p>
-            <a:pPr indent="0" marL="0">
-              <a:buNone/>
-            </a:pPr>
-            <a:endParaRPr lang="en-US" dirty="0"/>
-          </a:p>
-        </p:txBody>
-      </p:sp>
-      <p:sp>
-        <p:nvSpPr>
-          <p:cNvPr id="44" name="Text 41"/>
-          <p:cNvSpPr/>
-          <p:nvPr/>
-        </p:nvSpPr>
-        <p:spPr>
-          <a:xfrm>
-            <a:off x="2725698" y="3448556"/>
-            <a:ext cx="227886" cy="227886"/>
-          </a:xfrm>
-          <a:prstGeom prst="rect">
-            <a:avLst/>
-          </a:prstGeom>
-          <a:noFill/>
-          <a:ln/>
-        </p:spPr>
-        <p:txBody>
-          <a:bodyPr wrap="none" lIns="0" tIns="0" rIns="0" bIns="0" rtlCol="0" anchor="ctr"/>
-          <a:lstStyle/>
-          <a:p>
-            <a:pPr algn="ctr" indent="0" marL="0">
-              <a:buNone/>
-            </a:pPr>
-            <a:r>
-              <a:rPr lang="en-US" sz="1547" dirty="0">
-                <a:solidFill>
-                  <a:srgbClr val="0F5132"/>
-                </a:solidFill>
-                <a:latin typeface="Segoe UI Symbol" pitchFamily="34" charset="0"/>
-                <a:ea typeface="Segoe UI Symbol" pitchFamily="34" charset="-122"/>
-                <a:cs typeface="Segoe UI Symbol" pitchFamily="34" charset="-120"/>
-              </a:rPr>
-              <a:t>✦</a:t>
-            </a:r>
-            <a:endParaRPr lang="en-US" sz="1547" dirty="0"/>
-          </a:p>
-        </p:txBody>
-      </p:sp>
-      <p:sp>
-        <p:nvSpPr>
-          <p:cNvPr id="45" name="Text 42"/>
-          <p:cNvSpPr/>
-          <p:nvPr/>
-        </p:nvSpPr>
-        <p:spPr>
-          <a:xfrm>
-            <a:off x="2689622" y="3798243"/>
-            <a:ext cx="1710928" cy="154305"/>
-          </a:xfrm>
-          <a:prstGeom prst="rect">
-            <a:avLst/>
-          </a:prstGeom>
-          <a:noFill/>
-          <a:ln/>
-        </p:spPr>
-        <p:txBody>
-          <a:bodyPr wrap="none" lIns="0" tIns="0" rIns="0" bIns="0" rtlCol="0" anchor="t"/>
-          <a:lstStyle/>
-          <a:p>
-            <a:pPr algn="l" indent="0" marL="0">
-              <a:lnSpc>
-                <a:spcPts val="1125"/>
-              </a:lnSpc>
-              <a:buNone/>
-            </a:pPr>
-            <a:r>
-              <a:rPr lang="en-US" sz="900" b="1" spc="-18" kern="0" dirty="0">
-                <a:solidFill>
-                  <a:srgbClr val="1A2B22"/>
-                </a:solidFill>
-                <a:latin typeface="Carlito" pitchFamily="34" charset="0"/>
-                <a:ea typeface="Carlito" pitchFamily="34" charset="-122"/>
-                <a:cs typeface="Carlito" pitchFamily="34" charset="-120"/>
-              </a:rPr>
-              <a:t>Tout est tracé</a:t>
-            </a:r>
-            <a:endParaRPr lang="en-US" sz="900" dirty="0"/>
-          </a:p>
-        </p:txBody>
-      </p:sp>
-      <p:sp>
-        <p:nvSpPr>
-          <p:cNvPr id="46" name="Text 43"/>
-          <p:cNvSpPr/>
-          <p:nvPr/>
-        </p:nvSpPr>
-        <p:spPr>
-          <a:xfrm>
-            <a:off x="2689622" y="3983980"/>
-            <a:ext cx="1710928" cy="510235"/>
-          </a:xfrm>
-          <a:prstGeom prst="rect">
-            <a:avLst/>
-          </a:prstGeom>
-          <a:noFill/>
-          <a:ln/>
-        </p:spPr>
-        <p:txBody>
-          <a:bodyPr wrap="square" lIns="0" tIns="0" rIns="0" bIns="0" rtlCol="0" anchor="t"/>
-          <a:lstStyle/>
-          <a:p>
-            <a:pPr algn="l" indent="0" marL="0">
-              <a:lnSpc>
-                <a:spcPts val="1090"/>
-              </a:lnSpc>
-              <a:buNone/>
-            </a:pPr>
-            <a:r>
-              <a:rPr lang="en-US" sz="800" dirty="0">
-                <a:solidFill>
-                  <a:srgbClr val="6B7C72"/>
-                </a:solidFill>
-                <a:latin typeface="Carlito" pitchFamily="34" charset="0"/>
-                <a:ea typeface="Carlito" pitchFamily="34" charset="-122"/>
-                <a:cs typeface="Carlito" pitchFamily="34" charset="-120"/>
-              </a:rPr>
-              <a:t>Chaque action de l'administrateur est enregistrée. On sait qui a fait quoi et quand.</a:t>
-            </a:r>
-            <a:endParaRPr lang="en-US" sz="800" dirty="0"/>
-          </a:p>
-        </p:txBody>
-      </p:sp>
-      <p:sp>
-        <p:nvSpPr>
-          <p:cNvPr id="47" name="Text 44"/>
-          <p:cNvSpPr/>
-          <p:nvPr/>
-        </p:nvSpPr>
-        <p:spPr>
-          <a:xfrm>
-            <a:off x="4622006" y="3291036"/>
-            <a:ext cx="1953816" cy="1452414"/>
-          </a:xfrm>
-          <a:prstGeom prst="roundRect">
-            <a:avLst>
-              <a:gd name="adj" fmla="val 10493"/>
-            </a:avLst>
-          </a:prstGeom>
-          <a:solidFill>
-            <a:srgbClr val="FFFFFF"/>
-          </a:solidFill>
-          <a:ln/>
-        </p:spPr>
-        <p:txBody>
-          <a:bodyPr wrap="square" rtlCol="0" anchor="ctr"/>
-          <a:lstStyle/>
-          <a:p>
-            <a:pPr indent="0" marL="0">
-              <a:buNone/>
-            </a:pPr>
-            <a:endParaRPr lang="en-US" dirty="0"/>
-          </a:p>
-        </p:txBody>
-      </p:sp>
-      <p:sp>
-        <p:nvSpPr>
-          <p:cNvPr id="48" name="Shape 45"/>
-          <p:cNvSpPr/>
-          <p:nvPr/>
-        </p:nvSpPr>
-        <p:spPr>
-          <a:xfrm>
-            <a:off x="4622006" y="3294608"/>
-            <a:ext cx="1953816" cy="0"/>
+      </p:sp>
+      <p:sp>
+        <p:nvSpPr>
+          <p:cNvPr id="40" name="Shape 37"/>
+          <p:cNvSpPr/>
+          <p:nvPr/>
+        </p:nvSpPr>
+        <p:spPr>
+          <a:xfrm>
+            <a:off x="3257550" y="4739878"/>
+            <a:ext cx="2628900" cy="0"/>
           </a:xfrm>
           <a:prstGeom prst="line">
             <a:avLst/>
@@ -14730,14 +14304,226 @@
       </p:sp>
       <p:sp>
         <p:nvSpPr>
-          <p:cNvPr id="49" name="Shape 46"/>
-          <p:cNvSpPr/>
-          <p:nvPr/>
-        </p:nvSpPr>
-        <p:spPr>
-          <a:xfrm>
-            <a:off x="6572250" y="3291036"/>
-            <a:ext cx="0" cy="1452414"/>
+          <p:cNvPr id="41" name="Shape 38"/>
+          <p:cNvSpPr/>
+          <p:nvPr/>
+        </p:nvSpPr>
+        <p:spPr>
+          <a:xfrm>
+            <a:off x="3268266" y="3298180"/>
+            <a:ext cx="0" cy="1445270"/>
+          </a:xfrm>
+          <a:prstGeom prst="line">
+            <a:avLst/>
+          </a:prstGeom>
+          <a:noFill/>
+          <a:ln w="21431">
+            <a:solidFill>
+              <a:srgbClr val="B89968"/>
+            </a:solidFill>
+            <a:prstDash val="solid"/>
+          </a:ln>
+        </p:spPr>
+      </p:sp>
+      <p:sp>
+        <p:nvSpPr>
+          <p:cNvPr id="42" name="Text 39"/>
+          <p:cNvSpPr/>
+          <p:nvPr/>
+        </p:nvSpPr>
+        <p:spPr>
+          <a:xfrm>
+            <a:off x="3393281" y="3419624"/>
+            <a:ext cx="300038" cy="300038"/>
+          </a:xfrm>
+          <a:prstGeom prst="roundRect">
+            <a:avLst>
+              <a:gd name="adj" fmla="val 31746"/>
+            </a:avLst>
+          </a:prstGeom>
+          <a:solidFill>
+            <a:srgbClr val="B89968">
+              <a:alpha val="14000"/>
+            </a:srgbClr>
+          </a:solidFill>
+          <a:ln/>
+        </p:spPr>
+        <p:txBody>
+          <a:bodyPr wrap="square" rtlCol="0" anchor="ctr"/>
+          <a:lstStyle/>
+          <a:p>
+            <a:pPr indent="0" marL="0">
+              <a:buNone/>
+            </a:pPr>
+            <a:endParaRPr lang="en-US" dirty="0"/>
+          </a:p>
+        </p:txBody>
+      </p:sp>
+      <p:sp>
+        <p:nvSpPr>
+          <p:cNvPr id="43" name="Text 40"/>
+          <p:cNvSpPr/>
+          <p:nvPr/>
+        </p:nvSpPr>
+        <p:spPr>
+          <a:xfrm>
+            <a:off x="3429357" y="3455700"/>
+            <a:ext cx="227886" cy="227886"/>
+          </a:xfrm>
+          <a:prstGeom prst="rect">
+            <a:avLst/>
+          </a:prstGeom>
+          <a:noFill/>
+          <a:ln/>
+        </p:spPr>
+        <p:txBody>
+          <a:bodyPr wrap="none" lIns="0" tIns="0" rIns="0" bIns="0" rtlCol="0" anchor="ctr"/>
+          <a:lstStyle/>
+          <a:p>
+            <a:pPr algn="ctr" indent="0" marL="0">
+              <a:buNone/>
+            </a:pPr>
+            <a:r>
+              <a:rPr lang="en-US" sz="1547" dirty="0">
+                <a:solidFill>
+                  <a:srgbClr val="B89968"/>
+                </a:solidFill>
+                <a:latin typeface="Segoe UI Symbol" pitchFamily="34" charset="0"/>
+                <a:ea typeface="Segoe UI Symbol" pitchFamily="34" charset="-122"/>
+                <a:cs typeface="Segoe UI Symbol" pitchFamily="34" charset="-120"/>
+              </a:rPr>
+              <a:t>⛨</a:t>
+            </a:r>
+            <a:endParaRPr lang="en-US" sz="1547" dirty="0"/>
+          </a:p>
+        </p:txBody>
+      </p:sp>
+      <p:sp>
+        <p:nvSpPr>
+          <p:cNvPr id="44" name="Text 41"/>
+          <p:cNvSpPr/>
+          <p:nvPr/>
+        </p:nvSpPr>
+        <p:spPr>
+          <a:xfrm>
+            <a:off x="3393281" y="3805386"/>
+            <a:ext cx="2371725" cy="154305"/>
+          </a:xfrm>
+          <a:prstGeom prst="rect">
+            <a:avLst/>
+          </a:prstGeom>
+          <a:noFill/>
+          <a:ln/>
+        </p:spPr>
+        <p:txBody>
+          <a:bodyPr wrap="none" lIns="0" tIns="0" rIns="0" bIns="0" rtlCol="0" anchor="t"/>
+          <a:lstStyle/>
+          <a:p>
+            <a:pPr algn="l" indent="0" marL="0">
+              <a:lnSpc>
+                <a:spcPts val="1125"/>
+              </a:lnSpc>
+              <a:buNone/>
+            </a:pPr>
+            <a:r>
+              <a:rPr lang="en-US" sz="900" b="1" spc="-18" kern="0" dirty="0">
+                <a:solidFill>
+                  <a:srgbClr val="1A2B22"/>
+                </a:solidFill>
+                <a:latin typeface="Carlito" pitchFamily="34" charset="0"/>
+                <a:ea typeface="Carlito" pitchFamily="34" charset="-122"/>
+                <a:cs typeface="Carlito" pitchFamily="34" charset="-120"/>
+              </a:rPr>
+              <a:t>Vérifications</a:t>
+            </a:r>
+            <a:endParaRPr lang="en-US" sz="900" dirty="0"/>
+          </a:p>
+        </p:txBody>
+      </p:sp>
+      <p:sp>
+        <p:nvSpPr>
+          <p:cNvPr id="45" name="Text 42"/>
+          <p:cNvSpPr/>
+          <p:nvPr/>
+        </p:nvSpPr>
+        <p:spPr>
+          <a:xfrm>
+            <a:off x="3393281" y="3991124"/>
+            <a:ext cx="2371725" cy="340157"/>
+          </a:xfrm>
+          <a:prstGeom prst="rect">
+            <a:avLst/>
+          </a:prstGeom>
+          <a:noFill/>
+          <a:ln/>
+        </p:spPr>
+        <p:txBody>
+          <a:bodyPr wrap="square" lIns="0" tIns="0" rIns="0" bIns="0" rtlCol="0" anchor="t"/>
+          <a:lstStyle/>
+          <a:p>
+            <a:pPr algn="l" indent="0" marL="0">
+              <a:lnSpc>
+                <a:spcPts val="1090"/>
+              </a:lnSpc>
+              <a:buNone/>
+            </a:pPr>
+            <a:r>
+              <a:rPr lang="en-US" sz="800" dirty="0">
+                <a:solidFill>
+                  <a:srgbClr val="6B7C72"/>
+                </a:solidFill>
+                <a:latin typeface="Carlito" pitchFamily="34" charset="0"/>
+                <a:ea typeface="Carlito" pitchFamily="34" charset="-122"/>
+                <a:cs typeface="Carlito" pitchFamily="34" charset="-120"/>
+              </a:rPr>
+              <a:t>On vérifie chaque photo envoyée : sa taille, son type, pour éviter les fichiers dangereux.</a:t>
+            </a:r>
+            <a:endParaRPr lang="en-US" sz="800" dirty="0"/>
+          </a:p>
+        </p:txBody>
+      </p:sp>
+      <p:sp>
+        <p:nvSpPr>
+          <p:cNvPr id="46" name="Text 43"/>
+          <p:cNvSpPr/>
+          <p:nvPr/>
+        </p:nvSpPr>
+        <p:spPr>
+          <a:xfrm>
+            <a:off x="6000750" y="3298180"/>
+            <a:ext cx="2628900" cy="1445270"/>
+          </a:xfrm>
+          <a:prstGeom prst="roundRect">
+            <a:avLst>
+              <a:gd name="adj" fmla="val 10545"/>
+            </a:avLst>
+          </a:prstGeom>
+          <a:solidFill>
+            <a:srgbClr val="FFFFFF"/>
+          </a:solidFill>
+          <a:ln/>
+        </p:spPr>
+        <p:txBody>
+          <a:bodyPr wrap="square" rtlCol="0" anchor="ctr"/>
+          <a:lstStyle/>
+          <a:p>
+            <a:pPr indent="0" marL="0">
+              <a:buNone/>
+            </a:pPr>
+            <a:endParaRPr lang="en-US" dirty="0"/>
+          </a:p>
+        </p:txBody>
+      </p:sp>
+      <p:sp>
+        <p:nvSpPr>
+          <p:cNvPr id="47" name="Shape 44"/>
+          <p:cNvSpPr/>
+          <p:nvPr/>
+        </p:nvSpPr>
+        <p:spPr>
+          <a:xfrm>
+            <a:off x="6000750" y="3301752"/>
+            <a:ext cx="2628900" cy="0"/>
           </a:xfrm>
           <a:prstGeom prst="line">
             <a:avLst/>
@@ -14753,14 +14539,14 @@
       </p:sp>
       <p:sp>
         <p:nvSpPr>
-          <p:cNvPr id="50" name="Shape 47"/>
-          <p:cNvSpPr/>
-          <p:nvPr/>
-        </p:nvSpPr>
-        <p:spPr>
-          <a:xfrm>
-            <a:off x="4622006" y="4739878"/>
-            <a:ext cx="1953816" cy="0"/>
+          <p:cNvPr id="48" name="Shape 45"/>
+          <p:cNvSpPr/>
+          <p:nvPr/>
+        </p:nvSpPr>
+        <p:spPr>
+          <a:xfrm>
+            <a:off x="8626078" y="3298180"/>
+            <a:ext cx="0" cy="1445270"/>
           </a:xfrm>
           <a:prstGeom prst="line">
             <a:avLst/>
@@ -14776,14 +14562,37 @@
       </p:sp>
       <p:sp>
         <p:nvSpPr>
-          <p:cNvPr id="51" name="Shape 48"/>
-          <p:cNvSpPr/>
-          <p:nvPr/>
-        </p:nvSpPr>
-        <p:spPr>
-          <a:xfrm>
-            <a:off x="4632722" y="3291036"/>
-            <a:ext cx="0" cy="1452414"/>
+          <p:cNvPr id="49" name="Shape 46"/>
+          <p:cNvSpPr/>
+          <p:nvPr/>
+        </p:nvSpPr>
+        <p:spPr>
+          <a:xfrm>
+            <a:off x="6000750" y="4739878"/>
+            <a:ext cx="2628900" cy="0"/>
+          </a:xfrm>
+          <a:prstGeom prst="line">
+            <a:avLst/>
+          </a:prstGeom>
+          <a:noFill/>
+          <a:ln w="7144">
+            <a:solidFill>
+              <a:srgbClr val="E5E0D5"/>
+            </a:solidFill>
+            <a:prstDash val="solid"/>
+          </a:ln>
+        </p:spPr>
+      </p:sp>
+      <p:sp>
+        <p:nvSpPr>
+          <p:cNvPr id="50" name="Shape 47"/>
+          <p:cNvSpPr/>
+          <p:nvPr/>
+        </p:nvSpPr>
+        <p:spPr>
+          <a:xfrm>
+            <a:off x="6011466" y="3298180"/>
+            <a:ext cx="0" cy="1445270"/>
           </a:xfrm>
           <a:prstGeom prst="line">
             <a:avLst/>
@@ -14799,13 +14608,13 @@
       </p:sp>
       <p:sp>
         <p:nvSpPr>
-          <p:cNvPr id="52" name="Text 49"/>
-          <p:cNvSpPr/>
-          <p:nvPr/>
-        </p:nvSpPr>
-        <p:spPr>
-          <a:xfrm>
-            <a:off x="4757738" y="3412480"/>
+          <p:cNvPr id="51" name="Text 48"/>
+          <p:cNvSpPr/>
+          <p:nvPr/>
+        </p:nvSpPr>
+        <p:spPr>
+          <a:xfrm>
+            <a:off x="6136481" y="3419624"/>
             <a:ext cx="300038" cy="300038"/>
           </a:xfrm>
           <a:prstGeom prst="roundRect">
@@ -14833,13 +14642,13 @@
       </p:sp>
       <p:sp>
         <p:nvSpPr>
-          <p:cNvPr id="53" name="Text 50"/>
-          <p:cNvSpPr/>
-          <p:nvPr/>
-        </p:nvSpPr>
-        <p:spPr>
-          <a:xfrm>
-            <a:off x="4793813" y="3448556"/>
+          <p:cNvPr id="52" name="Text 49"/>
+          <p:cNvSpPr/>
+          <p:nvPr/>
+        </p:nvSpPr>
+        <p:spPr>
+          <a:xfrm>
+            <a:off x="6172557" y="3455700"/>
             <a:ext cx="227886" cy="227886"/>
           </a:xfrm>
           <a:prstGeom prst="rect">
@@ -14864,7 +14673,7 @@
                 <a:ea typeface="Segoe UI Symbol" pitchFamily="34" charset="-122"/>
                 <a:cs typeface="Segoe UI Symbol" pitchFamily="34" charset="-120"/>
               </a:rPr>
-              <a:t>⛨</a:t>
+              <a:t>✦</a:t>
             </a:r>
             <a:endParaRPr lang="en-US" sz="1547" dirty="0"/>
           </a:p>
@@ -14872,14 +14681,14 @@
       </p:sp>
       <p:sp>
         <p:nvSpPr>
-          <p:cNvPr id="54" name="Text 51"/>
-          <p:cNvSpPr/>
-          <p:nvPr/>
-        </p:nvSpPr>
-        <p:spPr>
-          <a:xfrm>
-            <a:off x="4757738" y="3798243"/>
-            <a:ext cx="1696641" cy="154305"/>
+          <p:cNvPr id="53" name="Text 50"/>
+          <p:cNvSpPr/>
+          <p:nvPr/>
+        </p:nvSpPr>
+        <p:spPr>
+          <a:xfrm>
+            <a:off x="6136481" y="3805386"/>
+            <a:ext cx="2371725" cy="154305"/>
           </a:xfrm>
           <a:prstGeom prst="rect">
             <a:avLst/>
@@ -14906,7 +14715,7 @@
                 <a:ea typeface="Carlito" pitchFamily="34" charset="-122"/>
                 <a:cs typeface="Carlito" pitchFamily="34" charset="-120"/>
               </a:rPr>
-              <a:t>Vérifications</a:t>
+              <a:t>Connexion chiffrée</a:t>
             </a:r>
             <a:endParaRPr lang="en-US" sz="900" dirty="0"/>
           </a:p>
@@ -14914,295 +14723,14 @@
       </p:sp>
       <p:sp>
         <p:nvSpPr>
-          <p:cNvPr id="55" name="Text 52"/>
-          <p:cNvSpPr/>
-          <p:nvPr/>
-        </p:nvSpPr>
-        <p:spPr>
-          <a:xfrm>
-            <a:off x="4757738" y="3983980"/>
-            <a:ext cx="1696641" cy="510235"/>
-          </a:xfrm>
-          <a:prstGeom prst="rect">
-            <a:avLst/>
-          </a:prstGeom>
-          <a:noFill/>
-          <a:ln/>
-        </p:spPr>
-        <p:txBody>
-          <a:bodyPr wrap="square" lIns="0" tIns="0" rIns="0" bIns="0" rtlCol="0" anchor="t"/>
-          <a:lstStyle/>
-          <a:p>
-            <a:pPr algn="l" indent="0" marL="0">
-              <a:lnSpc>
-                <a:spcPts val="1090"/>
-              </a:lnSpc>
-              <a:buNone/>
-            </a:pPr>
-            <a:r>
-              <a:rPr lang="en-US" sz="800" dirty="0">
-                <a:solidFill>
-                  <a:srgbClr val="6B7C72"/>
-                </a:solidFill>
-                <a:latin typeface="Carlito" pitchFamily="34" charset="0"/>
-                <a:ea typeface="Carlito" pitchFamily="34" charset="-122"/>
-                <a:cs typeface="Carlito" pitchFamily="34" charset="-120"/>
-              </a:rPr>
-              <a:t>On vérifie chaque photo envoyée : sa taille, son type, pour éviter les fichiers dangereux.</a:t>
-            </a:r>
-            <a:endParaRPr lang="en-US" sz="800" dirty="0"/>
-          </a:p>
-        </p:txBody>
-      </p:sp>
-      <p:sp>
-        <p:nvSpPr>
-          <p:cNvPr id="56" name="Text 53"/>
-          <p:cNvSpPr/>
-          <p:nvPr/>
-        </p:nvSpPr>
-        <p:spPr>
-          <a:xfrm>
-            <a:off x="6675834" y="3291036"/>
-            <a:ext cx="1953816" cy="1452414"/>
-          </a:xfrm>
-          <a:prstGeom prst="roundRect">
-            <a:avLst>
-              <a:gd name="adj" fmla="val 10493"/>
-            </a:avLst>
-          </a:prstGeom>
-          <a:solidFill>
-            <a:srgbClr val="FFFFFF"/>
-          </a:solidFill>
-          <a:ln/>
-        </p:spPr>
-        <p:txBody>
-          <a:bodyPr wrap="square" rtlCol="0" anchor="ctr"/>
-          <a:lstStyle/>
-          <a:p>
-            <a:pPr indent="0" marL="0">
-              <a:buNone/>
-            </a:pPr>
-            <a:endParaRPr lang="en-US" dirty="0"/>
-          </a:p>
-        </p:txBody>
-      </p:sp>
-      <p:sp>
-        <p:nvSpPr>
-          <p:cNvPr id="57" name="Shape 54"/>
-          <p:cNvSpPr/>
-          <p:nvPr/>
-        </p:nvSpPr>
-        <p:spPr>
-          <a:xfrm>
-            <a:off x="6675834" y="3294608"/>
-            <a:ext cx="1953816" cy="0"/>
-          </a:xfrm>
-          <a:prstGeom prst="line">
-            <a:avLst/>
-          </a:prstGeom>
-          <a:noFill/>
-          <a:ln w="7144">
-            <a:solidFill>
-              <a:srgbClr val="E5E0D5"/>
-            </a:solidFill>
-            <a:prstDash val="solid"/>
-          </a:ln>
-        </p:spPr>
-      </p:sp>
-      <p:sp>
-        <p:nvSpPr>
-          <p:cNvPr id="58" name="Shape 55"/>
-          <p:cNvSpPr/>
-          <p:nvPr/>
-        </p:nvSpPr>
-        <p:spPr>
-          <a:xfrm>
-            <a:off x="8626078" y="3291036"/>
-            <a:ext cx="0" cy="1452414"/>
-          </a:xfrm>
-          <a:prstGeom prst="line">
-            <a:avLst/>
-          </a:prstGeom>
-          <a:noFill/>
-          <a:ln w="7144">
-            <a:solidFill>
-              <a:srgbClr val="E5E0D5"/>
-            </a:solidFill>
-            <a:prstDash val="solid"/>
-          </a:ln>
-        </p:spPr>
-      </p:sp>
-      <p:sp>
-        <p:nvSpPr>
-          <p:cNvPr id="59" name="Shape 56"/>
-          <p:cNvSpPr/>
-          <p:nvPr/>
-        </p:nvSpPr>
-        <p:spPr>
-          <a:xfrm>
-            <a:off x="6675834" y="4739878"/>
-            <a:ext cx="1953816" cy="0"/>
-          </a:xfrm>
-          <a:prstGeom prst="line">
-            <a:avLst/>
-          </a:prstGeom>
-          <a:noFill/>
-          <a:ln w="7144">
-            <a:solidFill>
-              <a:srgbClr val="E5E0D5"/>
-            </a:solidFill>
-            <a:prstDash val="solid"/>
-          </a:ln>
-        </p:spPr>
-      </p:sp>
-      <p:sp>
-        <p:nvSpPr>
-          <p:cNvPr id="60" name="Shape 57"/>
-          <p:cNvSpPr/>
-          <p:nvPr/>
-        </p:nvSpPr>
-        <p:spPr>
-          <a:xfrm>
-            <a:off x="6686550" y="3291036"/>
-            <a:ext cx="0" cy="1452414"/>
-          </a:xfrm>
-          <a:prstGeom prst="line">
-            <a:avLst/>
-          </a:prstGeom>
-          <a:noFill/>
-          <a:ln w="21431">
-            <a:solidFill>
-              <a:srgbClr val="B89968"/>
-            </a:solidFill>
-            <a:prstDash val="solid"/>
-          </a:ln>
-        </p:spPr>
-      </p:sp>
-      <p:sp>
-        <p:nvSpPr>
-          <p:cNvPr id="61" name="Text 58"/>
-          <p:cNvSpPr/>
-          <p:nvPr/>
-        </p:nvSpPr>
-        <p:spPr>
-          <a:xfrm>
-            <a:off x="6811566" y="3412480"/>
-            <a:ext cx="300038" cy="300038"/>
-          </a:xfrm>
-          <a:prstGeom prst="roundRect">
-            <a:avLst>
-              <a:gd name="adj" fmla="val 31746"/>
-            </a:avLst>
-          </a:prstGeom>
-          <a:solidFill>
-            <a:srgbClr val="B89968">
-              <a:alpha val="14000"/>
-            </a:srgbClr>
-          </a:solidFill>
-          <a:ln/>
-        </p:spPr>
-        <p:txBody>
-          <a:bodyPr wrap="square" rtlCol="0" anchor="ctr"/>
-          <a:lstStyle/>
-          <a:p>
-            <a:pPr indent="0" marL="0">
-              <a:buNone/>
-            </a:pPr>
-            <a:endParaRPr lang="en-US" dirty="0"/>
-          </a:p>
-        </p:txBody>
-      </p:sp>
-      <p:sp>
-        <p:nvSpPr>
-          <p:cNvPr id="62" name="Text 59"/>
-          <p:cNvSpPr/>
-          <p:nvPr/>
-        </p:nvSpPr>
-        <p:spPr>
-          <a:xfrm>
-            <a:off x="6847642" y="3448556"/>
-            <a:ext cx="227886" cy="227886"/>
-          </a:xfrm>
-          <a:prstGeom prst="rect">
-            <a:avLst/>
-          </a:prstGeom>
-          <a:noFill/>
-          <a:ln/>
-        </p:spPr>
-        <p:txBody>
-          <a:bodyPr wrap="none" lIns="0" tIns="0" rIns="0" bIns="0" rtlCol="0" anchor="ctr"/>
-          <a:lstStyle/>
-          <a:p>
-            <a:pPr algn="ctr" indent="0" marL="0">
-              <a:buNone/>
-            </a:pPr>
-            <a:r>
-              <a:rPr lang="en-US" sz="1547" dirty="0">
-                <a:solidFill>
-                  <a:srgbClr val="B89968"/>
-                </a:solidFill>
-                <a:latin typeface="Segoe UI Symbol" pitchFamily="34" charset="0"/>
-                <a:ea typeface="Segoe UI Symbol" pitchFamily="34" charset="-122"/>
-                <a:cs typeface="Segoe UI Symbol" pitchFamily="34" charset="-120"/>
-              </a:rPr>
-              <a:t>✦</a:t>
-            </a:r>
-            <a:endParaRPr lang="en-US" sz="1547" dirty="0"/>
-          </a:p>
-        </p:txBody>
-      </p:sp>
-      <p:sp>
-        <p:nvSpPr>
-          <p:cNvPr id="63" name="Text 60"/>
-          <p:cNvSpPr/>
-          <p:nvPr/>
-        </p:nvSpPr>
-        <p:spPr>
-          <a:xfrm>
-            <a:off x="6811566" y="3798243"/>
-            <a:ext cx="1696641" cy="154305"/>
-          </a:xfrm>
-          <a:prstGeom prst="rect">
-            <a:avLst/>
-          </a:prstGeom>
-          <a:noFill/>
-          <a:ln/>
-        </p:spPr>
-        <p:txBody>
-          <a:bodyPr wrap="none" lIns="0" tIns="0" rIns="0" bIns="0" rtlCol="0" anchor="t"/>
-          <a:lstStyle/>
-          <a:p>
-            <a:pPr algn="l" indent="0" marL="0">
-              <a:lnSpc>
-                <a:spcPts val="1125"/>
-              </a:lnSpc>
-              <a:buNone/>
-            </a:pPr>
-            <a:r>
-              <a:rPr lang="en-US" sz="900" b="1" spc="-18" kern="0" dirty="0">
-                <a:solidFill>
-                  <a:srgbClr val="1A2B22"/>
-                </a:solidFill>
-                <a:latin typeface="Carlito" pitchFamily="34" charset="0"/>
-                <a:ea typeface="Carlito" pitchFamily="34" charset="-122"/>
-                <a:cs typeface="Carlito" pitchFamily="34" charset="-120"/>
-              </a:rPr>
-              <a:t>Connexion chiffrée</a:t>
-            </a:r>
-            <a:endParaRPr lang="en-US" sz="900" dirty="0"/>
-          </a:p>
-        </p:txBody>
-      </p:sp>
-      <p:sp>
-        <p:nvSpPr>
-          <p:cNvPr id="64" name="Text 61"/>
-          <p:cNvSpPr/>
-          <p:nvPr/>
-        </p:nvSpPr>
-        <p:spPr>
-          <a:xfrm>
-            <a:off x="6811566" y="3983980"/>
-            <a:ext cx="1696641" cy="510235"/>
+          <p:cNvPr id="54" name="Text 51"/>
+          <p:cNvSpPr/>
+          <p:nvPr/>
+        </p:nvSpPr>
+        <p:spPr>
+          <a:xfrm>
+            <a:off x="6136481" y="3991124"/>
+            <a:ext cx="2371725" cy="340157"/>
           </a:xfrm>
           <a:prstGeom prst="rect">
             <a:avLst/>
@@ -16279,11 +15807,11 @@
                     <a:alpha val="70000"/>
                   </a:srgbClr>
                 </a:solidFill>
-                <a:latin typeface="Liberation Sans Narrow" pitchFamily="34" charset="0"/>
-                <a:ea typeface="Liberation Sans Narrow" pitchFamily="34" charset="-122"/>
-                <a:cs typeface="Liberation Sans Narrow" pitchFamily="34" charset="-120"/>
-              </a:rPr>
-              <a:t>1348 pharmacies du fichier officiel</a:t>
+                <a:latin typeface="Carlito" pitchFamily="34" charset="0"/>
+                <a:ea typeface="Carlito" pitchFamily="34" charset="-122"/>
+                <a:cs typeface="Carlito" pitchFamily="34" charset="-120"/>
+              </a:rPr>
+              <a:t>une centaine de pharmacies couvertes</a:t>
             </a:r>
             <a:endParaRPr lang="en-US" sz="800" dirty="0"/>
           </a:p>
@@ -17764,7 +17292,7 @@
                 <a:ea typeface="Carlito" pitchFamily="34" charset="-122"/>
                 <a:cs typeface="Carlito" pitchFamily="34" charset="-120"/>
               </a:rPr>
-              <a:t>✓ 1348 pharmacies de garde sont déjà importées</a:t>
+              <a:t>✓ La liste des pharmacies de garde est déjà importée</a:t>
             </a:r>
             <a:endParaRPr lang="en-US" sz="900" dirty="0"/>
           </a:p>
@@ -17812,7 +17340,7 @@
                 <a:ea typeface="Carlito" pitchFamily="34" charset="-122"/>
                 <a:cs typeface="Carlito" pitchFamily="34" charset="-120"/>
               </a:rPr>
-              <a:t>✓ Le code source est public sur GitHub</a:t>
+              <a:t>✓ La documentation est complète</a:t>
             </a:r>
             <a:endParaRPr lang="en-US" sz="900" dirty="0"/>
           </a:p>

</xml_diff>